<commit_message>
Update 신문지 퍼즐 assets and add ZIP slides
Co-Authored-By: Claude Opus 4.6 (1M context) <noreply@anthropic.com>
</commit_message>
<xml_diff>
--- a/public/downloads/games/newspaper-puzzle/rules.pptx
+++ b/public/downloads/games/newspaper-puzzle/rules.pptx
@@ -22,20 +22,17 @@
     <p:sldId id="270" r:id="rId20"/>
     <p:sldId id="271" r:id="rId21"/>
     <p:sldId id="272" r:id="rId22"/>
+    <p:sldId id="273" r:id="rId23"/>
   </p:sldIdLst>
   <p:sldSz cx="18288000" cy="10287000"/>
   <p:notesSz cx="6858000" cy="9144000"/>
   <p:embeddedFontLst>
     <p:embeddedFont>
-      <p:font typeface="Jua" charset="1" panose="00000000000000000000"/>
-      <p:regular r:id="rId23"/>
-    </p:embeddedFont>
-    <p:embeddedFont>
-      <p:font typeface="TDTD갬성명조" charset="1" panose="02000503000000000000"/>
+      <p:font typeface="무궁화 고딕" charset="1" panose="02020603020101020101"/>
       <p:regular r:id="rId24"/>
     </p:embeddedFont>
     <p:embeddedFont>
-      <p:font typeface="TDTD가온" charset="1" panose="02000503000000000000"/>
+      <p:font typeface="무궁화 고딕 Bold" charset="1" panose="02020603020101020101"/>
       <p:regular r:id="rId25"/>
     </p:embeddedFont>
   </p:embeddedFontLst>
@@ -3154,8 +3151,8 @@
         </p:nvSpPr>
         <p:spPr>
           <a:xfrm rot="0">
-            <a:off x="1028700" y="3892867"/>
-            <a:ext cx="15555091" cy="2200275"/>
+            <a:off x="1028700" y="4178617"/>
+            <a:ext cx="15555091" cy="1914525"/>
           </a:xfrm>
           <a:prstGeom prst="rect">
             <a:avLst/>
@@ -3177,10 +3174,10 @@
                 <a:solidFill>
                   <a:srgbClr val="FFFAEF"/>
                 </a:solidFill>
-                <a:latin typeface="Jua"/>
-                <a:ea typeface="Jua"/>
-                <a:cs typeface="Jua"/>
-                <a:sym typeface="Jua"/>
+                <a:latin typeface="무궁화 고딕"/>
+                <a:ea typeface="무궁화 고딕"/>
+                <a:cs typeface="무궁화 고딕"/>
+                <a:sym typeface="무궁화 고딕"/>
               </a:rPr>
               <a:t>신문지 퍼즐</a:t>
             </a:r>
@@ -3195,8 +3192,8 @@
         </p:nvSpPr>
         <p:spPr>
           <a:xfrm rot="0">
-            <a:off x="15264803" y="9812655"/>
-            <a:ext cx="2637975" cy="474345"/>
+            <a:off x="14222066" y="9822180"/>
+            <a:ext cx="3680712" cy="464820"/>
           </a:xfrm>
           <a:prstGeom prst="rect">
             <a:avLst/>
@@ -3221,10 +3218,10 @@
                 <a:solidFill>
                   <a:srgbClr val="FFFFFF"/>
                 </a:solidFill>
-                <a:latin typeface="TDTD갬성명조"/>
-                <a:ea typeface="TDTD갬성명조"/>
-                <a:cs typeface="TDTD갬성명조"/>
-                <a:sym typeface="TDTD갬성명조"/>
+                <a:latin typeface="무궁화 고딕"/>
+                <a:ea typeface="무궁화 고딕"/>
+                <a:cs typeface="무궁화 고딕"/>
+                <a:sym typeface="무궁화 고딕"/>
               </a:rPr>
               <a:t>ⓒ 2026. Sunday Play</a:t>
             </a:r>
@@ -3321,8 +3318,8 @@
         </p:nvSpPr>
         <p:spPr>
           <a:xfrm rot="0">
-            <a:off x="2717556" y="3895725"/>
-            <a:ext cx="12852888" cy="2200275"/>
+            <a:off x="2717556" y="4181475"/>
+            <a:ext cx="12852888" cy="1914525"/>
           </a:xfrm>
           <a:prstGeom prst="rect">
             <a:avLst/>
@@ -3344,12 +3341,12 @@
                 <a:solidFill>
                   <a:srgbClr val="000000"/>
                 </a:solidFill>
-                <a:latin typeface="Jua"/>
-                <a:ea typeface="Jua"/>
-                <a:cs typeface="Jua"/>
-                <a:sym typeface="Jua"/>
+                <a:latin typeface="무궁화 고딕"/>
+                <a:ea typeface="무궁화 고딕"/>
+                <a:cs typeface="무궁화 고딕"/>
+                <a:sym typeface="무궁화 고딕"/>
               </a:rPr>
-              <a:t>십자가</a:t>
+              <a:t>예수님</a:t>
             </a:r>
           </a:p>
         </p:txBody>
@@ -3444,8 +3441,8 @@
         </p:nvSpPr>
         <p:spPr>
           <a:xfrm rot="0">
-            <a:off x="2717556" y="3895725"/>
-            <a:ext cx="12852888" cy="2200275"/>
+            <a:off x="2717556" y="4181475"/>
+            <a:ext cx="12852888" cy="1914525"/>
           </a:xfrm>
           <a:prstGeom prst="rect">
             <a:avLst/>
@@ -3467,12 +3464,12 @@
                 <a:solidFill>
                   <a:srgbClr val="000000"/>
                 </a:solidFill>
-                <a:latin typeface="Jua"/>
-                <a:ea typeface="Jua"/>
-                <a:cs typeface="Jua"/>
-                <a:sym typeface="Jua"/>
+                <a:latin typeface="무궁화 고딕"/>
+                <a:ea typeface="무궁화 고딕"/>
+                <a:cs typeface="무궁화 고딕"/>
+                <a:sym typeface="무궁화 고딕"/>
               </a:rPr>
-              <a:t>부활절</a:t>
+              <a:t>십자가</a:t>
             </a:r>
           </a:p>
         </p:txBody>
@@ -3567,8 +3564,8 @@
         </p:nvSpPr>
         <p:spPr>
           <a:xfrm rot="0">
-            <a:off x="2717556" y="3895725"/>
-            <a:ext cx="12852888" cy="2200275"/>
+            <a:off x="2717556" y="4181475"/>
+            <a:ext cx="12852888" cy="1914525"/>
           </a:xfrm>
           <a:prstGeom prst="rect">
             <a:avLst/>
@@ -3590,12 +3587,12 @@
                 <a:solidFill>
                   <a:srgbClr val="000000"/>
                 </a:solidFill>
-                <a:latin typeface="Jua"/>
-                <a:ea typeface="Jua"/>
-                <a:cs typeface="Jua"/>
-                <a:sym typeface="Jua"/>
+                <a:latin typeface="무궁화 고딕"/>
+                <a:ea typeface="무궁화 고딕"/>
+                <a:cs typeface="무궁화 고딕"/>
+                <a:sym typeface="무궁화 고딕"/>
               </a:rPr>
-              <a:t>감사합니다</a:t>
+              <a:t>부활절</a:t>
             </a:r>
           </a:p>
         </p:txBody>
@@ -3690,8 +3687,8 @@
         </p:nvSpPr>
         <p:spPr>
           <a:xfrm rot="0">
-            <a:off x="2717556" y="3895725"/>
-            <a:ext cx="12852888" cy="2200275"/>
+            <a:off x="2717556" y="4181475"/>
+            <a:ext cx="12852888" cy="1914525"/>
           </a:xfrm>
           <a:prstGeom prst="rect">
             <a:avLst/>
@@ -3713,12 +3710,12 @@
                 <a:solidFill>
                   <a:srgbClr val="000000"/>
                 </a:solidFill>
-                <a:latin typeface="Jua"/>
-                <a:ea typeface="Jua"/>
-                <a:cs typeface="Jua"/>
-                <a:sym typeface="Jua"/>
+                <a:latin typeface="무궁화 고딕"/>
+                <a:ea typeface="무궁화 고딕"/>
+                <a:cs typeface="무궁화 고딕"/>
+                <a:sym typeface="무궁화 고딕"/>
               </a:rPr>
-              <a:t>축복합니다</a:t>
+              <a:t>감사합니다</a:t>
             </a:r>
           </a:p>
         </p:txBody>
@@ -3813,8 +3810,8 @@
         </p:nvSpPr>
         <p:spPr>
           <a:xfrm rot="0">
-            <a:off x="2717556" y="3895725"/>
-            <a:ext cx="12852888" cy="2200275"/>
+            <a:off x="2717556" y="4181475"/>
+            <a:ext cx="12852888" cy="1914525"/>
           </a:xfrm>
           <a:prstGeom prst="rect">
             <a:avLst/>
@@ -3836,12 +3833,12 @@
                 <a:solidFill>
                   <a:srgbClr val="000000"/>
                 </a:solidFill>
-                <a:latin typeface="Jua"/>
-                <a:ea typeface="Jua"/>
-                <a:cs typeface="Jua"/>
-                <a:sym typeface="Jua"/>
+                <a:latin typeface="무궁화 고딕"/>
+                <a:ea typeface="무궁화 고딕"/>
+                <a:cs typeface="무궁화 고딕"/>
+                <a:sym typeface="무궁화 고딕"/>
               </a:rPr>
-              <a:t>쉬지 말고 기도하라</a:t>
+              <a:t>축복합니다</a:t>
             </a:r>
           </a:p>
         </p:txBody>
@@ -3936,8 +3933,8 @@
         </p:nvSpPr>
         <p:spPr>
           <a:xfrm rot="0">
-            <a:off x="2717556" y="3895725"/>
-            <a:ext cx="12852888" cy="2200275"/>
+            <a:off x="2717556" y="4181475"/>
+            <a:ext cx="12852888" cy="1914525"/>
           </a:xfrm>
           <a:prstGeom prst="rect">
             <a:avLst/>
@@ -3959,12 +3956,12 @@
                 <a:solidFill>
                   <a:srgbClr val="000000"/>
                 </a:solidFill>
-                <a:latin typeface="Jua"/>
-                <a:ea typeface="Jua"/>
-                <a:cs typeface="Jua"/>
-                <a:sym typeface="Jua"/>
+                <a:latin typeface="무궁화 고딕"/>
+                <a:ea typeface="무궁화 고딕"/>
+                <a:cs typeface="무궁화 고딕"/>
+                <a:sym typeface="무궁화 고딕"/>
               </a:rPr>
-              <a:t>하나님은 사랑이시라</a:t>
+              <a:t>쉬지 말고 기도하라</a:t>
             </a:r>
           </a:p>
         </p:txBody>
@@ -4059,8 +4056,8 @@
         </p:nvSpPr>
         <p:spPr>
           <a:xfrm rot="0">
-            <a:off x="2717556" y="3895725"/>
-            <a:ext cx="12852888" cy="2200275"/>
+            <a:off x="2717556" y="4219575"/>
+            <a:ext cx="12852888" cy="1838325"/>
           </a:xfrm>
           <a:prstGeom prst="rect">
             <a:avLst/>
@@ -4074,20 +4071,20 @@
           <a:p>
             <a:pPr algn="ctr">
               <a:lnSpc>
-                <a:spcPts val="15000"/>
+                <a:spcPts val="14400"/>
               </a:lnSpc>
             </a:pPr>
             <a:r>
-              <a:rPr lang="en-US" sz="12500">
+              <a:rPr lang="en-US" sz="12000">
                 <a:solidFill>
                   <a:srgbClr val="000000"/>
                 </a:solidFill>
-                <a:latin typeface="Jua"/>
-                <a:ea typeface="Jua"/>
-                <a:cs typeface="Jua"/>
-                <a:sym typeface="Jua"/>
+                <a:latin typeface="무궁화 고딕"/>
+                <a:ea typeface="무궁화 고딕"/>
+                <a:cs typeface="무궁화 고딕"/>
+                <a:sym typeface="무궁화 고딕"/>
               </a:rPr>
-              <a:t>범사에 감사하라</a:t>
+              <a:t>하나님은 사랑이시라</a:t>
             </a:r>
           </a:p>
         </p:txBody>
@@ -4140,25 +4137,50 @@
           </a:stretch>
         </p:blipFill>
         <p:spPr>
-          <a:xfrm flipH="false" flipV="false" rot="-7408585">
-            <a:off x="4499355" y="-533795"/>
-            <a:ext cx="9289290" cy="10369815"/>
+          <a:xfrm flipH="false" flipV="false" rot="0">
+            <a:off x="13655377" y="6809666"/>
+            <a:ext cx="6229999" cy="6954669"/>
           </a:xfrm>
           <a:prstGeom prst="rect">
             <a:avLst/>
           </a:prstGeom>
         </p:spPr>
       </p:pic>
-      <p:sp>
-        <p:nvSpPr>
-          <p:cNvPr name="TextBox 3" id="3"/>
+      <p:pic>
+        <p:nvPicPr>
+          <p:cNvPr name="Picture 3" id="3"/>
+          <p:cNvPicPr>
+            <a:picLocks noChangeAspect="true"/>
+          </p:cNvPicPr>
+          <p:nvPr/>
+        </p:nvPicPr>
+        <p:blipFill>
+          <a:blip r:embed="rId3"/>
+          <a:srcRect l="0" t="0" r="0" b="0"/>
+          <a:stretch>
+            <a:fillRect/>
+          </a:stretch>
+        </p:blipFill>
+        <p:spPr>
+          <a:xfrm flipH="false" flipV="false" rot="0">
+            <a:off x="0" y="0"/>
+            <a:ext cx="6925457" cy="4700654"/>
+          </a:xfrm>
+          <a:prstGeom prst="rect">
+            <a:avLst/>
+          </a:prstGeom>
+        </p:spPr>
+      </p:pic>
+      <p:sp>
+        <p:nvSpPr>
+          <p:cNvPr name="TextBox 4" id="4"/>
           <p:cNvSpPr txBox="true"/>
           <p:nvPr/>
         </p:nvSpPr>
         <p:spPr>
           <a:xfrm rot="0">
-            <a:off x="4421807" y="3895725"/>
-            <a:ext cx="9444385" cy="2200275"/>
+            <a:off x="2717556" y="4181475"/>
+            <a:ext cx="12852888" cy="1914525"/>
           </a:xfrm>
           <a:prstGeom prst="rect">
             <a:avLst/>
@@ -4180,10 +4202,108 @@
                 <a:solidFill>
                   <a:srgbClr val="000000"/>
                 </a:solidFill>
-                <a:latin typeface="Jua"/>
-                <a:ea typeface="Jua"/>
-                <a:cs typeface="Jua"/>
-                <a:sym typeface="Jua"/>
+                <a:latin typeface="무궁화 고딕"/>
+                <a:ea typeface="무궁화 고딕"/>
+                <a:cs typeface="무궁화 고딕"/>
+                <a:sym typeface="무궁화 고딕"/>
+              </a:rPr>
+              <a:t>범사에 감사하라</a:t>
+            </a:r>
+          </a:p>
+        </p:txBody>
+      </p:sp>
+    </p:spTree>
+  </p:cSld>
+  <p:clrMapOvr>
+    <a:masterClrMapping/>
+  </p:clrMapOvr>
+</p:sld>
+</file>
+
+<file path=ppt/slides/slide18.xml><?xml version="1.0" encoding="utf-8"?>
+<p:sld xmlns:p="http://schemas.openxmlformats.org/presentationml/2006/main" xmlns:a="http://schemas.openxmlformats.org/drawingml/2006/main" xmlns:r="http://schemas.openxmlformats.org/officeDocument/2006/relationships">
+  <p:cSld>
+    <p:bg>
+      <p:bgPr>
+        <a:solidFill>
+          <a:srgbClr val="FFFAEF"/>
+        </a:solidFill>
+      </p:bgPr>
+    </p:bg>
+    <p:spTree>
+      <p:nvGrpSpPr>
+        <p:cNvPr id="1" name=""/>
+        <p:cNvGrpSpPr/>
+        <p:nvPr/>
+      </p:nvGrpSpPr>
+      <p:grpSpPr>
+        <a:xfrm>
+          <a:off x="0" y="0"/>
+          <a:ext cx="0" cy="0"/>
+          <a:chOff x="0" y="0"/>
+          <a:chExt cx="0" cy="0"/>
+        </a:xfrm>
+      </p:grpSpPr>
+      <p:pic>
+        <p:nvPicPr>
+          <p:cNvPr name="Picture 2" id="2"/>
+          <p:cNvPicPr>
+            <a:picLocks noChangeAspect="true"/>
+          </p:cNvPicPr>
+          <p:nvPr/>
+        </p:nvPicPr>
+        <p:blipFill>
+          <a:blip r:embed="rId2"/>
+          <a:srcRect l="0" t="0" r="0" b="0"/>
+          <a:stretch>
+            <a:fillRect/>
+          </a:stretch>
+        </p:blipFill>
+        <p:spPr>
+          <a:xfrm flipH="false" flipV="false" rot="-7408585">
+            <a:off x="4499355" y="-533795"/>
+            <a:ext cx="9289290" cy="10369815"/>
+          </a:xfrm>
+          <a:prstGeom prst="rect">
+            <a:avLst/>
+          </a:prstGeom>
+        </p:spPr>
+      </p:pic>
+      <p:sp>
+        <p:nvSpPr>
+          <p:cNvPr name="TextBox 3" id="3"/>
+          <p:cNvSpPr txBox="true"/>
+          <p:nvPr/>
+        </p:nvSpPr>
+        <p:spPr>
+          <a:xfrm rot="0">
+            <a:off x="4421807" y="4181475"/>
+            <a:ext cx="9444385" cy="1914525"/>
+          </a:xfrm>
+          <a:prstGeom prst="rect">
+            <a:avLst/>
+          </a:prstGeom>
+        </p:spPr>
+        <p:txBody>
+          <a:bodyPr anchor="t" rtlCol="false" tIns="0" lIns="0" bIns="0" rIns="0">
+            <a:spAutoFit/>
+          </a:bodyPr>
+          <a:lstStyle/>
+          <a:p>
+            <a:pPr algn="ctr">
+              <a:lnSpc>
+                <a:spcPts val="15000"/>
+              </a:lnSpc>
+            </a:pPr>
+            <a:r>
+              <a:rPr lang="en-US" sz="12500">
+                <a:solidFill>
+                  <a:srgbClr val="000000"/>
+                </a:solidFill>
+                <a:latin typeface="무궁화 고딕"/>
+                <a:ea typeface="무궁화 고딕"/>
+                <a:cs typeface="무궁화 고딕"/>
+                <a:sym typeface="무궁화 고딕"/>
               </a:rPr>
               <a:t>감사합니다!</a:t>
             </a:r>
@@ -4382,8 +4502,8 @@
         </p:nvSpPr>
         <p:spPr>
           <a:xfrm rot="0">
-            <a:off x="11392761" y="600705"/>
-            <a:ext cx="5362043" cy="1600200"/>
+            <a:off x="11392761" y="819780"/>
+            <a:ext cx="5362043" cy="1381125"/>
           </a:xfrm>
           <a:prstGeom prst="rect">
             <a:avLst/>
@@ -4405,10 +4525,10 @@
                 <a:solidFill>
                   <a:srgbClr val="FFFAEF"/>
                 </a:solidFill>
-                <a:latin typeface="Jua"/>
-                <a:ea typeface="Jua"/>
-                <a:cs typeface="Jua"/>
-                <a:sym typeface="Jua"/>
+                <a:latin typeface="무궁화 고딕"/>
+                <a:ea typeface="무궁화 고딕"/>
+                <a:cs typeface="무궁화 고딕"/>
+                <a:sym typeface="무궁화 고딕"/>
               </a:rPr>
               <a:t>규칙</a:t>
             </a:r>
@@ -4424,9 +4544,9 @@
         <p:grpSpPr>
           <a:xfrm rot="0">
             <a:off x="309172" y="535073"/>
-            <a:ext cx="9230801" cy="2942330"/>
+            <a:ext cx="9230801" cy="2601393"/>
             <a:chOff x="0" y="0"/>
-            <a:chExt cx="12307735" cy="3923107"/>
+            <a:chExt cx="12307735" cy="3468524"/>
           </a:xfrm>
         </p:grpSpPr>
         <p:sp>
@@ -4437,8 +4557,8 @@
           </p:nvSpPr>
           <p:spPr>
             <a:xfrm rot="0">
-              <a:off x="0" y="1625465"/>
-              <a:ext cx="12307735" cy="2297642"/>
+              <a:off x="0" y="1648191"/>
+              <a:ext cx="12307735" cy="1820333"/>
             </a:xfrm>
             <a:prstGeom prst="rect">
               <a:avLst/>
@@ -4452,18 +4572,18 @@
             <a:p>
               <a:pPr algn="l">
                 <a:lnSpc>
-                  <a:spcPts val="7000"/>
+                  <a:spcPts val="5599"/>
                 </a:lnSpc>
               </a:pPr>
               <a:r>
-                <a:rPr lang="en-US" sz="5000">
+                <a:rPr lang="en-US" sz="3999">
                   <a:solidFill>
                     <a:srgbClr val="FFFAEF"/>
                   </a:solidFill>
-                  <a:latin typeface="TDTD가온"/>
-                  <a:ea typeface="TDTD가온"/>
-                  <a:cs typeface="TDTD가온"/>
-                  <a:sym typeface="TDTD가온"/>
+                  <a:latin typeface="무궁화 고딕"/>
+                  <a:ea typeface="무궁화 고딕"/>
+                  <a:cs typeface="무궁화 고딕"/>
+                  <a:sym typeface="무궁화 고딕"/>
                 </a:rPr>
                 <a:t>팀을 나누고 각 팀에게 신문지, 가위, 풀, 도화지를 나눠줍니다.</a:t>
               </a:r>
@@ -4478,8 +4598,8 @@
           </p:nvSpPr>
           <p:spPr>
             <a:xfrm rot="0">
-              <a:off x="0" y="-190500"/>
-              <a:ext cx="11298371" cy="1367863"/>
+              <a:off x="0" y="-66675"/>
+              <a:ext cx="11298371" cy="1238189"/>
             </a:xfrm>
             <a:prstGeom prst="rect">
               <a:avLst/>
@@ -4501,10 +4621,10 @@
                   <a:solidFill>
                     <a:srgbClr val="FFFAEF"/>
                   </a:solidFill>
-                  <a:latin typeface="Jua"/>
-                  <a:ea typeface="Jua"/>
-                  <a:cs typeface="Jua"/>
-                  <a:sym typeface="Jua"/>
+                  <a:latin typeface="무궁화 고딕 Bold"/>
+                  <a:ea typeface="무궁화 고딕 Bold"/>
+                  <a:cs typeface="무궁화 고딕 Bold"/>
+                  <a:sym typeface="무궁화 고딕 Bold"/>
                 </a:rPr>
                 <a:t>STEP 1.</a:t>
               </a:r>
@@ -4520,10 +4640,10 @@
         </p:nvGrpSpPr>
         <p:grpSpPr>
           <a:xfrm rot="0">
-            <a:off x="10161695" y="7950306"/>
-            <a:ext cx="7985937" cy="1994512"/>
+            <a:off x="10402326" y="8200435"/>
+            <a:ext cx="7745305" cy="1838937"/>
             <a:chOff x="0" y="0"/>
-            <a:chExt cx="10647916" cy="2659349"/>
+            <a:chExt cx="10327074" cy="2451916"/>
           </a:xfrm>
         </p:grpSpPr>
         <p:sp>
@@ -4534,8 +4654,8 @@
           </p:nvSpPr>
           <p:spPr>
             <a:xfrm rot="0">
-              <a:off x="0" y="1542808"/>
-              <a:ext cx="10546685" cy="1116541"/>
+              <a:off x="0" y="1571383"/>
+              <a:ext cx="10228893" cy="880533"/>
             </a:xfrm>
             <a:prstGeom prst="rect">
               <a:avLst/>
@@ -4549,18 +4669,18 @@
             <a:p>
               <a:pPr algn="l">
                 <a:lnSpc>
-                  <a:spcPts val="7000"/>
+                  <a:spcPts val="5599"/>
                 </a:lnSpc>
               </a:pPr>
               <a:r>
-                <a:rPr lang="en-US" sz="5000">
+                <a:rPr lang="en-US" sz="3999">
                   <a:solidFill>
                     <a:srgbClr val="FFFAEF"/>
                   </a:solidFill>
-                  <a:latin typeface="TDTD가온"/>
-                  <a:ea typeface="TDTD가온"/>
-                  <a:cs typeface="TDTD가온"/>
-                  <a:sym typeface="TDTD가온"/>
+                  <a:latin typeface="무궁화 고딕"/>
+                  <a:ea typeface="무궁화 고딕"/>
+                  <a:cs typeface="무궁화 고딕"/>
+                  <a:sym typeface="무궁화 고딕"/>
                 </a:rPr>
                 <a:t>가장 빨리 단어를 완성한 팀이 우승!</a:t>
               </a:r>
@@ -4575,8 +4695,8 @@
           </p:nvSpPr>
           <p:spPr>
             <a:xfrm rot="0">
-              <a:off x="0" y="-190500"/>
-              <a:ext cx="10647916" cy="1374479"/>
+              <a:off x="0" y="-57150"/>
+              <a:ext cx="10327074" cy="1241129"/>
             </a:xfrm>
             <a:prstGeom prst="rect">
               <a:avLst/>
@@ -4598,10 +4718,10 @@
                   <a:solidFill>
                     <a:srgbClr val="FFFAEF"/>
                   </a:solidFill>
-                  <a:latin typeface="Jua"/>
-                  <a:ea typeface="Jua"/>
-                  <a:cs typeface="Jua"/>
-                  <a:sym typeface="Jua"/>
+                  <a:latin typeface="무궁화 고딕 Bold"/>
+                  <a:ea typeface="무궁화 고딕 Bold"/>
+                  <a:cs typeface="무궁화 고딕 Bold"/>
+                  <a:sym typeface="무궁화 고딕 Bold"/>
                 </a:rPr>
                 <a:t>STEP 3.</a:t>
               </a:r>
@@ -4617,10 +4737,10 @@
         </p:nvGrpSpPr>
         <p:grpSpPr>
           <a:xfrm rot="0">
-            <a:off x="5138458" y="4089110"/>
-            <a:ext cx="9737287" cy="2939517"/>
+            <a:off x="4275356" y="4370035"/>
+            <a:ext cx="9737287" cy="2596832"/>
             <a:chOff x="0" y="0"/>
-            <a:chExt cx="12983050" cy="3919356"/>
+            <a:chExt cx="12983050" cy="3462442"/>
           </a:xfrm>
         </p:grpSpPr>
         <p:sp>
@@ -4631,8 +4751,8 @@
           </p:nvSpPr>
           <p:spPr>
             <a:xfrm rot="0">
-              <a:off x="0" y="1631121"/>
-              <a:ext cx="12983050" cy="2288235"/>
+              <a:off x="0" y="1642109"/>
+              <a:ext cx="12983050" cy="1820333"/>
             </a:xfrm>
             <a:prstGeom prst="rect">
               <a:avLst/>
@@ -4646,18 +4766,18 @@
             <a:p>
               <a:pPr algn="l">
                 <a:lnSpc>
-                  <a:spcPts val="6995"/>
+                  <a:spcPts val="5599"/>
                 </a:lnSpc>
               </a:pPr>
               <a:r>
-                <a:rPr lang="en-US" sz="4996">
+                <a:rPr lang="en-US" sz="3999">
                   <a:solidFill>
                     <a:srgbClr val="FFFAEF"/>
                   </a:solidFill>
-                  <a:latin typeface="TDTD가온"/>
-                  <a:ea typeface="TDTD가온"/>
-                  <a:cs typeface="TDTD가온"/>
-                  <a:sym typeface="TDTD가온"/>
+                  <a:latin typeface="무궁화 고딕"/>
+                  <a:ea typeface="무궁화 고딕"/>
+                  <a:cs typeface="무궁화 고딕"/>
+                  <a:sym typeface="무궁화 고딕"/>
                 </a:rPr>
                 <a:t>주어진 단어가 공개되면, 신문지에서</a:t>
               </a:r>
@@ -4665,18 +4785,18 @@
             <a:p>
               <a:pPr algn="l">
                 <a:lnSpc>
-                  <a:spcPts val="6995"/>
+                  <a:spcPts val="5599"/>
                 </a:lnSpc>
               </a:pPr>
               <a:r>
-                <a:rPr lang="en-US" sz="4996">
+                <a:rPr lang="en-US" sz="3999">
                   <a:solidFill>
                     <a:srgbClr val="FFFAEF"/>
                   </a:solidFill>
-                  <a:latin typeface="TDTD가온"/>
-                  <a:ea typeface="TDTD가온"/>
-                  <a:cs typeface="TDTD가온"/>
-                  <a:sym typeface="TDTD가온"/>
+                  <a:latin typeface="무궁화 고딕"/>
+                  <a:ea typeface="무궁화 고딕"/>
+                  <a:cs typeface="무궁화 고딕"/>
+                  <a:sym typeface="무궁화 고딕"/>
                 </a:rPr>
                 <a:t>글자를 찾아 오려서 도화지에 붙이세요!</a:t>
               </a:r>
@@ -4691,8 +4811,8 @@
           </p:nvSpPr>
           <p:spPr>
             <a:xfrm rot="0">
-              <a:off x="0" y="-190500"/>
-              <a:ext cx="5799240" cy="1369906"/>
+              <a:off x="0" y="-66675"/>
+              <a:ext cx="5799240" cy="1238018"/>
             </a:xfrm>
             <a:prstGeom prst="rect">
               <a:avLst/>
@@ -4714,10 +4834,10 @@
                   <a:solidFill>
                     <a:srgbClr val="FFFAEF"/>
                   </a:solidFill>
-                  <a:latin typeface="Jua"/>
-                  <a:ea typeface="Jua"/>
-                  <a:cs typeface="Jua"/>
-                  <a:sym typeface="Jua"/>
+                  <a:latin typeface="무궁화 고딕 Bold"/>
+                  <a:ea typeface="무궁화 고딕 Bold"/>
+                  <a:cs typeface="무궁화 고딕 Bold"/>
+                  <a:sym typeface="무궁화 고딕 Bold"/>
                 </a:rPr>
                 <a:t>STEP 2.</a:t>
               </a:r>
@@ -4734,6 +4854,129 @@
 </file>
 
 <file path=ppt/slides/slide3.xml><?xml version="1.0" encoding="utf-8"?>
+<p:sld xmlns:p="http://schemas.openxmlformats.org/presentationml/2006/main" xmlns:a="http://schemas.openxmlformats.org/drawingml/2006/main" xmlns:r="http://schemas.openxmlformats.org/officeDocument/2006/relationships">
+  <p:cSld>
+    <p:bg>
+      <p:bgPr>
+        <a:solidFill>
+          <a:srgbClr val="FFFAEF"/>
+        </a:solidFill>
+      </p:bgPr>
+    </p:bg>
+    <p:spTree>
+      <p:nvGrpSpPr>
+        <p:cNvPr id="1" name=""/>
+        <p:cNvGrpSpPr/>
+        <p:nvPr/>
+      </p:nvGrpSpPr>
+      <p:grpSpPr>
+        <a:xfrm>
+          <a:off x="0" y="0"/>
+          <a:ext cx="0" cy="0"/>
+          <a:chOff x="0" y="0"/>
+          <a:chExt cx="0" cy="0"/>
+        </a:xfrm>
+      </p:grpSpPr>
+      <p:sp>
+        <p:nvSpPr>
+          <p:cNvPr name="TextBox 2" id="2"/>
+          <p:cNvSpPr txBox="true"/>
+          <p:nvPr/>
+        </p:nvSpPr>
+        <p:spPr>
+          <a:xfrm rot="0">
+            <a:off x="3238925" y="4378545"/>
+            <a:ext cx="11810151" cy="1914525"/>
+          </a:xfrm>
+          <a:prstGeom prst="rect">
+            <a:avLst/>
+          </a:prstGeom>
+        </p:spPr>
+        <p:txBody>
+          <a:bodyPr anchor="t" rtlCol="false" tIns="0" lIns="0" bIns="0" rIns="0">
+            <a:spAutoFit/>
+          </a:bodyPr>
+          <a:lstStyle/>
+          <a:p>
+            <a:pPr algn="ctr">
+              <a:lnSpc>
+                <a:spcPts val="15000"/>
+              </a:lnSpc>
+            </a:pPr>
+            <a:r>
+              <a:rPr lang="en-US" sz="12500">
+                <a:solidFill>
+                  <a:srgbClr val="000000"/>
+                </a:solidFill>
+                <a:latin typeface="무궁화 고딕"/>
+                <a:ea typeface="무궁화 고딕"/>
+                <a:cs typeface="무궁화 고딕"/>
+                <a:sym typeface="무궁화 고딕"/>
+              </a:rPr>
+              <a:t>팀을 나눠주세요!</a:t>
+            </a:r>
+          </a:p>
+        </p:txBody>
+      </p:sp>
+      <p:pic>
+        <p:nvPicPr>
+          <p:cNvPr name="Picture 3" id="3"/>
+          <p:cNvPicPr>
+            <a:picLocks noChangeAspect="true"/>
+          </p:cNvPicPr>
+          <p:nvPr/>
+        </p:nvPicPr>
+        <p:blipFill>
+          <a:blip r:embed="rId2"/>
+          <a:srcRect l="0" t="0" r="0" b="0"/>
+          <a:stretch>
+            <a:fillRect/>
+          </a:stretch>
+        </p:blipFill>
+        <p:spPr>
+          <a:xfrm flipH="false" flipV="false" rot="0">
+            <a:off x="13655377" y="6809666"/>
+            <a:ext cx="6229999" cy="6954669"/>
+          </a:xfrm>
+          <a:prstGeom prst="rect">
+            <a:avLst/>
+          </a:prstGeom>
+        </p:spPr>
+      </p:pic>
+      <p:pic>
+        <p:nvPicPr>
+          <p:cNvPr name="Picture 4" id="4"/>
+          <p:cNvPicPr>
+            <a:picLocks noChangeAspect="true"/>
+          </p:cNvPicPr>
+          <p:nvPr/>
+        </p:nvPicPr>
+        <p:blipFill>
+          <a:blip r:embed="rId3"/>
+          <a:srcRect l="0" t="0" r="0" b="0"/>
+          <a:stretch>
+            <a:fillRect/>
+          </a:stretch>
+        </p:blipFill>
+        <p:spPr>
+          <a:xfrm flipH="false" flipV="false" rot="0">
+            <a:off x="0" y="0"/>
+            <a:ext cx="6925457" cy="4700654"/>
+          </a:xfrm>
+          <a:prstGeom prst="rect">
+            <a:avLst/>
+          </a:prstGeom>
+        </p:spPr>
+      </p:pic>
+    </p:spTree>
+  </p:cSld>
+  <p:clrMapOvr>
+    <a:masterClrMapping/>
+  </p:clrMapOvr>
+</p:sld>
+</file>
+
+<file path=ppt/slides/slide4.xml><?xml version="1.0" encoding="utf-8"?>
 <p:sld xmlns:p="http://schemas.openxmlformats.org/presentationml/2006/main" xmlns:a="http://schemas.openxmlformats.org/drawingml/2006/main" xmlns:r="http://schemas.openxmlformats.org/officeDocument/2006/relationships">
   <p:cSld>
     <p:bg>
@@ -4815,8 +5058,8 @@
         </p:nvSpPr>
         <p:spPr>
           <a:xfrm rot="0">
-            <a:off x="1028700" y="3892867"/>
-            <a:ext cx="15555091" cy="2200275"/>
+            <a:off x="1028700" y="4178617"/>
+            <a:ext cx="15555091" cy="1914525"/>
           </a:xfrm>
           <a:prstGeom prst="rect">
             <a:avLst/>
@@ -4838,10 +5081,10 @@
                 <a:solidFill>
                   <a:srgbClr val="FFFAEF"/>
                 </a:solidFill>
-                <a:latin typeface="Jua"/>
-                <a:ea typeface="Jua"/>
-                <a:cs typeface="Jua"/>
-                <a:sym typeface="Jua"/>
+                <a:latin typeface="무궁화 고딕"/>
+                <a:ea typeface="무궁화 고딕"/>
+                <a:cs typeface="무궁화 고딕"/>
+                <a:sym typeface="무궁화 고딕"/>
               </a:rPr>
               <a:t>신문지 퍼즐</a:t>
             </a:r>
@@ -4856,8 +5099,8 @@
         </p:nvSpPr>
         <p:spPr>
           <a:xfrm rot="0">
-            <a:off x="15264803" y="9812655"/>
-            <a:ext cx="2637975" cy="474345"/>
+            <a:off x="14222066" y="9822180"/>
+            <a:ext cx="3680712" cy="464820"/>
           </a:xfrm>
           <a:prstGeom prst="rect">
             <a:avLst/>
@@ -4882,135 +5125,12 @@
                 <a:solidFill>
                   <a:srgbClr val="FFFFFF"/>
                 </a:solidFill>
-                <a:latin typeface="TDTD갬성명조"/>
-                <a:ea typeface="TDTD갬성명조"/>
-                <a:cs typeface="TDTD갬성명조"/>
-                <a:sym typeface="TDTD갬성명조"/>
+                <a:latin typeface="무궁화 고딕"/>
+                <a:ea typeface="무궁화 고딕"/>
+                <a:cs typeface="무궁화 고딕"/>
+                <a:sym typeface="무궁화 고딕"/>
               </a:rPr>
               <a:t>ⓒ 2026. Sunday Play</a:t>
-            </a:r>
-          </a:p>
-        </p:txBody>
-      </p:sp>
-    </p:spTree>
-  </p:cSld>
-  <p:clrMapOvr>
-    <a:masterClrMapping/>
-  </p:clrMapOvr>
-</p:sld>
-</file>
-
-<file path=ppt/slides/slide4.xml><?xml version="1.0" encoding="utf-8"?>
-<p:sld xmlns:p="http://schemas.openxmlformats.org/presentationml/2006/main" xmlns:a="http://schemas.openxmlformats.org/drawingml/2006/main" xmlns:r="http://schemas.openxmlformats.org/officeDocument/2006/relationships">
-  <p:cSld>
-    <p:bg>
-      <p:bgPr>
-        <a:solidFill>
-          <a:srgbClr val="FFFAEF"/>
-        </a:solidFill>
-      </p:bgPr>
-    </p:bg>
-    <p:spTree>
-      <p:nvGrpSpPr>
-        <p:cNvPr id="1" name=""/>
-        <p:cNvGrpSpPr/>
-        <p:nvPr/>
-      </p:nvGrpSpPr>
-      <p:grpSpPr>
-        <a:xfrm>
-          <a:off x="0" y="0"/>
-          <a:ext cx="0" cy="0"/>
-          <a:chOff x="0" y="0"/>
-          <a:chExt cx="0" cy="0"/>
-        </a:xfrm>
-      </p:grpSpPr>
-      <p:pic>
-        <p:nvPicPr>
-          <p:cNvPr name="Picture 2" id="2"/>
-          <p:cNvPicPr>
-            <a:picLocks noChangeAspect="true"/>
-          </p:cNvPicPr>
-          <p:nvPr/>
-        </p:nvPicPr>
-        <p:blipFill>
-          <a:blip r:embed="rId2"/>
-          <a:srcRect l="0" t="0" r="0" b="0"/>
-          <a:stretch>
-            <a:fillRect/>
-          </a:stretch>
-        </p:blipFill>
-        <p:spPr>
-          <a:xfrm flipH="false" flipV="false" rot="0">
-            <a:off x="13655377" y="6809666"/>
-            <a:ext cx="6229999" cy="6954669"/>
-          </a:xfrm>
-          <a:prstGeom prst="rect">
-            <a:avLst/>
-          </a:prstGeom>
-        </p:spPr>
-      </p:pic>
-      <p:pic>
-        <p:nvPicPr>
-          <p:cNvPr name="Picture 3" id="3"/>
-          <p:cNvPicPr>
-            <a:picLocks noChangeAspect="true"/>
-          </p:cNvPicPr>
-          <p:nvPr/>
-        </p:nvPicPr>
-        <p:blipFill>
-          <a:blip r:embed="rId3"/>
-          <a:srcRect l="0" t="0" r="0" b="0"/>
-          <a:stretch>
-            <a:fillRect/>
-          </a:stretch>
-        </p:blipFill>
-        <p:spPr>
-          <a:xfrm flipH="false" flipV="false" rot="0">
-            <a:off x="0" y="0"/>
-            <a:ext cx="6925457" cy="4700654"/>
-          </a:xfrm>
-          <a:prstGeom prst="rect">
-            <a:avLst/>
-          </a:prstGeom>
-        </p:spPr>
-      </p:pic>
-      <p:sp>
-        <p:nvSpPr>
-          <p:cNvPr name="TextBox 4" id="4"/>
-          <p:cNvSpPr txBox="true"/>
-          <p:nvPr/>
-        </p:nvSpPr>
-        <p:spPr>
-          <a:xfrm rot="0">
-            <a:off x="2717556" y="3895725"/>
-            <a:ext cx="12852888" cy="2200275"/>
-          </a:xfrm>
-          <a:prstGeom prst="rect">
-            <a:avLst/>
-          </a:prstGeom>
-        </p:spPr>
-        <p:txBody>
-          <a:bodyPr anchor="t" rtlCol="false" tIns="0" lIns="0" bIns="0" rIns="0">
-            <a:spAutoFit/>
-          </a:bodyPr>
-          <a:lstStyle/>
-          <a:p>
-            <a:pPr algn="ctr">
-              <a:lnSpc>
-                <a:spcPts val="15000"/>
-              </a:lnSpc>
-            </a:pPr>
-            <a:r>
-              <a:rPr lang="en-US" sz="12500">
-                <a:solidFill>
-                  <a:srgbClr val="000000"/>
-                </a:solidFill>
-                <a:latin typeface="Jua"/>
-                <a:ea typeface="Jua"/>
-                <a:cs typeface="Jua"/>
-                <a:sym typeface="Jua"/>
-              </a:rPr>
-              <a:t>사랑</a:t>
             </a:r>
           </a:p>
         </p:txBody>
@@ -5105,8 +5225,8 @@
         </p:nvSpPr>
         <p:spPr>
           <a:xfrm rot="0">
-            <a:off x="2717556" y="3895725"/>
-            <a:ext cx="12852888" cy="2200275"/>
+            <a:off x="2717556" y="4181475"/>
+            <a:ext cx="12852888" cy="1914525"/>
           </a:xfrm>
           <a:prstGeom prst="rect">
             <a:avLst/>
@@ -5128,12 +5248,12 @@
                 <a:solidFill>
                   <a:srgbClr val="000000"/>
                 </a:solidFill>
-                <a:latin typeface="Jua"/>
-                <a:ea typeface="Jua"/>
-                <a:cs typeface="Jua"/>
-                <a:sym typeface="Jua"/>
+                <a:latin typeface="무궁화 고딕"/>
+                <a:ea typeface="무궁화 고딕"/>
+                <a:cs typeface="무궁화 고딕"/>
+                <a:sym typeface="무궁화 고딕"/>
               </a:rPr>
-              <a:t>감사</a:t>
+              <a:t>사랑</a:t>
             </a:r>
           </a:p>
         </p:txBody>
@@ -5228,8 +5348,8 @@
         </p:nvSpPr>
         <p:spPr>
           <a:xfrm rot="0">
-            <a:off x="2717556" y="3895725"/>
-            <a:ext cx="12852888" cy="2200275"/>
+            <a:off x="2717556" y="4181475"/>
+            <a:ext cx="12852888" cy="1914525"/>
           </a:xfrm>
           <a:prstGeom prst="rect">
             <a:avLst/>
@@ -5251,12 +5371,12 @@
                 <a:solidFill>
                   <a:srgbClr val="000000"/>
                 </a:solidFill>
-                <a:latin typeface="Jua"/>
-                <a:ea typeface="Jua"/>
-                <a:cs typeface="Jua"/>
-                <a:sym typeface="Jua"/>
+                <a:latin typeface="무궁화 고딕"/>
+                <a:ea typeface="무궁화 고딕"/>
+                <a:cs typeface="무궁화 고딕"/>
+                <a:sym typeface="무궁화 고딕"/>
               </a:rPr>
-              <a:t>은혜</a:t>
+              <a:t>감사</a:t>
             </a:r>
           </a:p>
         </p:txBody>
@@ -5351,8 +5471,8 @@
         </p:nvSpPr>
         <p:spPr>
           <a:xfrm rot="0">
-            <a:off x="2717556" y="3895725"/>
-            <a:ext cx="12852888" cy="2200275"/>
+            <a:off x="2717556" y="4181475"/>
+            <a:ext cx="12852888" cy="1914525"/>
           </a:xfrm>
           <a:prstGeom prst="rect">
             <a:avLst/>
@@ -5374,12 +5494,12 @@
                 <a:solidFill>
                   <a:srgbClr val="000000"/>
                 </a:solidFill>
-                <a:latin typeface="Jua"/>
-                <a:ea typeface="Jua"/>
-                <a:cs typeface="Jua"/>
-                <a:sym typeface="Jua"/>
+                <a:latin typeface="무궁화 고딕"/>
+                <a:ea typeface="무궁화 고딕"/>
+                <a:cs typeface="무궁화 고딕"/>
+                <a:sym typeface="무궁화 고딕"/>
               </a:rPr>
-              <a:t>기쁨</a:t>
+              <a:t>은혜</a:t>
             </a:r>
           </a:p>
         </p:txBody>
@@ -5474,8 +5594,8 @@
         </p:nvSpPr>
         <p:spPr>
           <a:xfrm rot="0">
-            <a:off x="2717556" y="3895725"/>
-            <a:ext cx="12852888" cy="2200275"/>
+            <a:off x="2717556" y="4181475"/>
+            <a:ext cx="12852888" cy="1914525"/>
           </a:xfrm>
           <a:prstGeom prst="rect">
             <a:avLst/>
@@ -5497,12 +5617,12 @@
                 <a:solidFill>
                   <a:srgbClr val="000000"/>
                 </a:solidFill>
-                <a:latin typeface="Jua"/>
-                <a:ea typeface="Jua"/>
-                <a:cs typeface="Jua"/>
-                <a:sym typeface="Jua"/>
+                <a:latin typeface="무궁화 고딕"/>
+                <a:ea typeface="무궁화 고딕"/>
+                <a:cs typeface="무궁화 고딕"/>
+                <a:sym typeface="무궁화 고딕"/>
               </a:rPr>
-              <a:t>소망</a:t>
+              <a:t>기쁨</a:t>
             </a:r>
           </a:p>
         </p:txBody>
@@ -5597,8 +5717,8 @@
         </p:nvSpPr>
         <p:spPr>
           <a:xfrm rot="0">
-            <a:off x="2717556" y="3895725"/>
-            <a:ext cx="12852888" cy="2200275"/>
+            <a:off x="2717556" y="4181475"/>
+            <a:ext cx="12852888" cy="1914525"/>
           </a:xfrm>
           <a:prstGeom prst="rect">
             <a:avLst/>
@@ -5620,12 +5740,12 @@
                 <a:solidFill>
                   <a:srgbClr val="000000"/>
                 </a:solidFill>
-                <a:latin typeface="Jua"/>
-                <a:ea typeface="Jua"/>
-                <a:cs typeface="Jua"/>
-                <a:sym typeface="Jua"/>
+                <a:latin typeface="무궁화 고딕"/>
+                <a:ea typeface="무궁화 고딕"/>
+                <a:cs typeface="무궁화 고딕"/>
+                <a:sym typeface="무궁화 고딕"/>
               </a:rPr>
-              <a:t>예수님</a:t>
+              <a:t>소망</a:t>
             </a:r>
           </a:p>
         </p:txBody>

</xml_diff>